<commit_message>
Add 'Alternatives considered' slide after stack rationale and renumber pages
</commit_message>
<xml_diff>
--- a/HostelHub-Presentation.pptx
+++ b/HostelHub-Presentation.pptx
@@ -11,6 +11,7 @@
     <p:sldId id="258" r:id="rId5"/>
     <p:sldId id="259" r:id="rId6"/>
     <p:sldId id="260" r:id="rId7"/>
+    <p:sldId id="274" r:id="rId24"/>
     <p:sldId id="261" r:id="rId8"/>
     <p:sldId id="262" r:id="rId9"/>
     <p:sldId id="263" r:id="rId10"/>
@@ -3657,7 +3658,7 @@
                 </a:solidFill>
                 <a:latin typeface="Aptos"/>
               </a:rPr>
-              <a:t>09</a:t>
+              <a:t>10</a:t>
             </a:r>
           </a:p>
         </p:txBody>
@@ -4015,7 +4016,7 @@
                 </a:solidFill>
                 <a:latin typeface="Aptos"/>
               </a:rPr>
-              <a:t>10</a:t>
+              <a:t>11</a:t>
             </a:r>
           </a:p>
         </p:txBody>
@@ -5325,7 +5326,7 @@
                 </a:solidFill>
                 <a:latin typeface="Aptos"/>
               </a:rPr>
-              <a:t>11</a:t>
+              <a:t>12</a:t>
             </a:r>
           </a:p>
         </p:txBody>
@@ -5763,7 +5764,7 @@
                 </a:solidFill>
                 <a:latin typeface="Aptos"/>
               </a:rPr>
-              <a:t>12</a:t>
+              <a:t>13</a:t>
             </a:r>
           </a:p>
         </p:txBody>
@@ -6265,7 +6266,7 @@
                 </a:solidFill>
                 <a:latin typeface="Aptos"/>
               </a:rPr>
-              <a:t>13</a:t>
+              <a:t>14</a:t>
             </a:r>
           </a:p>
         </p:txBody>
@@ -6813,7 +6814,7 @@
                 </a:solidFill>
                 <a:latin typeface="Aptos"/>
               </a:rPr>
-              <a:t>14</a:t>
+              <a:t>15</a:t>
             </a:r>
           </a:p>
         </p:txBody>
@@ -7493,7 +7494,7 @@
                 </a:solidFill>
                 <a:latin typeface="Aptos"/>
               </a:rPr>
-              <a:t>15</a:t>
+              <a:t>16</a:t>
             </a:r>
           </a:p>
         </p:txBody>
@@ -8041,7 +8042,7 @@
                 </a:solidFill>
                 <a:latin typeface="Aptos"/>
               </a:rPr>
-              <a:t>16</a:t>
+              <a:t>17</a:t>
             </a:r>
           </a:p>
         </p:txBody>
@@ -8649,6 +8650,977 @@
 </p:sld>
 </file>
 
+<file path=ppt/slides/slide19.xml><?xml version="1.0" encoding="utf-8"?>
+<p:sld xmlns:a="http://schemas.openxmlformats.org/drawingml/2006/main" xmlns:p="http://schemas.openxmlformats.org/presentationml/2006/main" xmlns:r="http://schemas.openxmlformats.org/officeDocument/2006/relationships">
+  <p:cSld>
+    <p:bg>
+      <p:bgPr>
+        <a:solidFill>
+          <a:srgbClr val="0D1424"/>
+        </a:solidFill>
+        <a:effectLst/>
+      </p:bgPr>
+    </p:bg>
+    <p:spTree>
+      <p:nvGrpSpPr>
+        <p:cNvPr id="1" name=""/>
+        <p:cNvGrpSpPr/>
+        <p:nvPr/>
+      </p:nvGrpSpPr>
+      <p:grpSpPr/>
+      <p:sp>
+        <p:nvSpPr>
+          <p:cNvPr id="2" name="TextBox 1"/>
+          <p:cNvSpPr txBox="1"/>
+          <p:nvPr/>
+        </p:nvSpPr>
+        <p:spPr>
+          <a:xfrm>
+            <a:off x="566928" y="292608"/>
+            <a:ext cx="10881360" cy="274320"/>
+          </a:xfrm>
+          <a:prstGeom prst="rect">
+            <a:avLst/>
+          </a:prstGeom>
+          <a:noFill/>
+        </p:spPr>
+        <p:txBody>
+          <a:bodyPr wrap="square" lIns="36576" tIns="36576" rIns="36576" bIns="36576" anchor="t">
+            <a:spAutoFit/>
+          </a:bodyPr>
+          <a:lstStyle/>
+          <a:p>
+            <a:r>
+              <a:rPr sz="1000" b="1">
+                <a:solidFill>
+                  <a:srgbClr val="45D3E6"/>
+                </a:solidFill>
+                <a:latin typeface="Aptos"/>
+              </a:rPr>
+              <a:t>04 / STACK RATIONALE</a:t>
+            </a:r>
+          </a:p>
+        </p:txBody>
+      </p:sp>
+      <p:sp>
+        <p:nvSpPr>
+          <p:cNvPr id="3" name="TextBox 2"/>
+          <p:cNvSpPr txBox="1"/>
+          <p:nvPr/>
+        </p:nvSpPr>
+        <p:spPr>
+          <a:xfrm>
+            <a:off x="566928" y="621792"/>
+            <a:ext cx="10972800" cy="502920"/>
+          </a:xfrm>
+          <a:prstGeom prst="rect">
+            <a:avLst/>
+          </a:prstGeom>
+          <a:noFill/>
+        </p:spPr>
+        <p:txBody>
+          <a:bodyPr wrap="square" lIns="36576" tIns="36576" rIns="36576" bIns="36576" anchor="t">
+            <a:spAutoFit/>
+          </a:bodyPr>
+          <a:lstStyle/>
+          <a:p>
+            <a:r>
+              <a:rPr sz="2700" b="1">
+                <a:solidFill>
+                  <a:srgbClr val="F3F7FC"/>
+                </a:solidFill>
+                <a:latin typeface="Aptos"/>
+              </a:rPr>
+              <a:t>Alternatives considered</a:t>
+            </a:r>
+          </a:p>
+        </p:txBody>
+      </p:sp>
+      <p:sp>
+        <p:nvSpPr>
+          <p:cNvPr id="4" name="Rectangle 3"/>
+          <p:cNvSpPr/>
+          <p:nvPr/>
+        </p:nvSpPr>
+        <p:spPr>
+          <a:xfrm>
+            <a:off x="566928" y="1207008"/>
+            <a:ext cx="914400" cy="41148"/>
+          </a:xfrm>
+          <a:prstGeom prst="rect">
+            <a:avLst/>
+          </a:prstGeom>
+          <a:solidFill>
+            <a:srgbClr val="45D3E6"/>
+          </a:solidFill>
+          <a:ln>
+            <a:noFill/>
+          </a:ln>
+        </p:spPr>
+        <p:style>
+          <a:lnRef idx="1">
+            <a:schemeClr val="accent1"/>
+          </a:lnRef>
+          <a:fillRef idx="3">
+            <a:schemeClr val="accent1"/>
+          </a:fillRef>
+          <a:effectRef idx="2">
+            <a:schemeClr val="accent1"/>
+          </a:effectRef>
+          <a:fontRef idx="minor">
+            <a:schemeClr val="lt1"/>
+          </a:fontRef>
+        </p:style>
+        <p:txBody>
+          <a:bodyPr rtlCol="0" anchor="ctr"/>
+          <a:lstStyle/>
+          <a:p>
+            <a:pPr algn="ctr"/>
+            <a:endParaRPr/>
+          </a:p>
+        </p:txBody>
+      </p:sp>
+      <p:sp>
+        <p:nvSpPr>
+          <p:cNvPr id="5" name="TextBox 4"/>
+          <p:cNvSpPr txBox="1"/>
+          <p:nvPr/>
+        </p:nvSpPr>
+        <p:spPr>
+          <a:xfrm>
+            <a:off x="11109960" y="6510528"/>
+            <a:ext cx="502920" cy="182880"/>
+          </a:xfrm>
+          <a:prstGeom prst="rect">
+            <a:avLst/>
+          </a:prstGeom>
+          <a:noFill/>
+        </p:spPr>
+        <p:txBody>
+          <a:bodyPr wrap="square" lIns="36576" tIns="36576" rIns="36576" bIns="36576" anchor="t">
+            <a:spAutoFit/>
+          </a:bodyPr>
+          <a:lstStyle/>
+          <a:p>
+            <a:pPr algn="r"/>
+            <a:r>
+              <a:rPr sz="900" b="1">
+                <a:solidFill>
+                  <a:srgbClr val="ADBBCF"/>
+                </a:solidFill>
+                <a:latin typeface="Aptos"/>
+              </a:rPr>
+              <a:t>06</a:t>
+            </a:r>
+          </a:p>
+        </p:txBody>
+      </p:sp>
+      <p:sp>
+        <p:nvSpPr>
+          <p:cNvPr id="6" name="Rounded Rectangle 5"/>
+          <p:cNvSpPr/>
+          <p:nvPr/>
+        </p:nvSpPr>
+        <p:spPr>
+          <a:xfrm>
+            <a:off x="658368" y="1444752"/>
+            <a:ext cx="2514600" cy="475488"/>
+          </a:xfrm>
+          <a:prstGeom prst="roundRect">
+            <a:avLst>
+              <a:gd name="adj" fmla="val 12000"/>
+            </a:avLst>
+          </a:prstGeom>
+          <a:solidFill>
+            <a:srgbClr val="1D2B44"/>
+          </a:solidFill>
+          <a:ln>
+            <a:noFill/>
+          </a:ln>
+        </p:spPr>
+        <p:style>
+          <a:lnRef idx="1">
+            <a:schemeClr val="accent1"/>
+          </a:lnRef>
+          <a:fillRef idx="3">
+            <a:schemeClr val="accent1"/>
+          </a:fillRef>
+          <a:effectRef idx="2">
+            <a:schemeClr val="accent1"/>
+          </a:effectRef>
+          <a:fontRef idx="minor">
+            <a:schemeClr val="lt1"/>
+          </a:fontRef>
+        </p:style>
+        <p:txBody>
+          <a:bodyPr rtlCol="0" anchor="ctr"/>
+          <a:lstStyle/>
+          <a:p>
+            <a:pPr algn="ctr"/>
+            <a:endParaRPr/>
+          </a:p>
+        </p:txBody>
+      </p:sp>
+      <p:sp>
+        <p:nvSpPr>
+          <p:cNvPr id="7" name="TextBox 6"/>
+          <p:cNvSpPr txBox="1"/>
+          <p:nvPr/>
+        </p:nvSpPr>
+        <p:spPr>
+          <a:xfrm>
+            <a:off x="804672" y="1527048"/>
+            <a:ext cx="2240280" cy="256032"/>
+          </a:xfrm>
+          <a:prstGeom prst="rect">
+            <a:avLst/>
+          </a:prstGeom>
+          <a:noFill/>
+        </p:spPr>
+        <p:txBody>
+          <a:bodyPr wrap="square" lIns="36576" tIns="36576" rIns="36576" bIns="36576" anchor="t">
+            <a:spAutoFit/>
+          </a:bodyPr>
+          <a:lstStyle/>
+          <a:p>
+            <a:r>
+              <a:rPr sz="1200" b="1">
+                <a:solidFill>
+                  <a:srgbClr val="45D3E6"/>
+                </a:solidFill>
+                <a:latin typeface="Aptos"/>
+              </a:rPr>
+              <a:t>FastAPI</a:t>
+            </a:r>
+          </a:p>
+        </p:txBody>
+      </p:sp>
+      <p:sp>
+        <p:nvSpPr>
+          <p:cNvPr id="8" name="TextBox 7"/>
+          <p:cNvSpPr txBox="1"/>
+          <p:nvPr/>
+        </p:nvSpPr>
+        <p:spPr>
+          <a:xfrm>
+            <a:off x="3429000" y="1508760"/>
+            <a:ext cx="7909560" cy="310896"/>
+          </a:xfrm>
+          <a:prstGeom prst="rect">
+            <a:avLst/>
+          </a:prstGeom>
+          <a:noFill/>
+        </p:spPr>
+        <p:txBody>
+          <a:bodyPr wrap="square" lIns="36576" tIns="36576" rIns="36576" bIns="36576" anchor="t">
+            <a:spAutoFit/>
+          </a:bodyPr>
+          <a:lstStyle/>
+          <a:p>
+            <a:r>
+              <a:rPr sz="1300" b="0">
+                <a:solidFill>
+                  <a:srgbClr val="F3F7FC"/>
+                </a:solidFill>
+                <a:latin typeface="Aptos"/>
+              </a:rPr>
+              <a:t>over Flask / Django: typed validation and Swagger docs built in</a:t>
+            </a:r>
+          </a:p>
+        </p:txBody>
+      </p:sp>
+      <p:sp>
+        <p:nvSpPr>
+          <p:cNvPr id="9" name="Rounded Rectangle 8"/>
+          <p:cNvSpPr/>
+          <p:nvPr/>
+        </p:nvSpPr>
+        <p:spPr>
+          <a:xfrm>
+            <a:off x="658368" y="2075688"/>
+            <a:ext cx="2514600" cy="475488"/>
+          </a:xfrm>
+          <a:prstGeom prst="roundRect">
+            <a:avLst>
+              <a:gd name="adj" fmla="val 12000"/>
+            </a:avLst>
+          </a:prstGeom>
+          <a:solidFill>
+            <a:srgbClr val="1D2B44"/>
+          </a:solidFill>
+          <a:ln>
+            <a:noFill/>
+          </a:ln>
+        </p:spPr>
+        <p:style>
+          <a:lnRef idx="1">
+            <a:schemeClr val="accent1"/>
+          </a:lnRef>
+          <a:fillRef idx="3">
+            <a:schemeClr val="accent1"/>
+          </a:fillRef>
+          <a:effectRef idx="2">
+            <a:schemeClr val="accent1"/>
+          </a:effectRef>
+          <a:fontRef idx="minor">
+            <a:schemeClr val="lt1"/>
+          </a:fontRef>
+        </p:style>
+        <p:txBody>
+          <a:bodyPr rtlCol="0" anchor="ctr"/>
+          <a:lstStyle/>
+          <a:p>
+            <a:pPr algn="ctr"/>
+            <a:endParaRPr/>
+          </a:p>
+        </p:txBody>
+      </p:sp>
+      <p:sp>
+        <p:nvSpPr>
+          <p:cNvPr id="10" name="TextBox 9"/>
+          <p:cNvSpPr txBox="1"/>
+          <p:nvPr/>
+        </p:nvSpPr>
+        <p:spPr>
+          <a:xfrm>
+            <a:off x="804672" y="2157984"/>
+            <a:ext cx="2240280" cy="256032"/>
+          </a:xfrm>
+          <a:prstGeom prst="rect">
+            <a:avLst/>
+          </a:prstGeom>
+          <a:noFill/>
+        </p:spPr>
+        <p:txBody>
+          <a:bodyPr wrap="square" lIns="36576" tIns="36576" rIns="36576" bIns="36576" anchor="t">
+            <a:spAutoFit/>
+          </a:bodyPr>
+          <a:lstStyle/>
+          <a:p>
+            <a:r>
+              <a:rPr sz="1200" b="1">
+                <a:solidFill>
+                  <a:srgbClr val="45D3E6"/>
+                </a:solidFill>
+                <a:latin typeface="Aptos"/>
+              </a:rPr>
+              <a:t>React + Vite</a:t>
+            </a:r>
+          </a:p>
+        </p:txBody>
+      </p:sp>
+      <p:sp>
+        <p:nvSpPr>
+          <p:cNvPr id="11" name="TextBox 10"/>
+          <p:cNvSpPr txBox="1"/>
+          <p:nvPr/>
+        </p:nvSpPr>
+        <p:spPr>
+          <a:xfrm>
+            <a:off x="3429000" y="2139696"/>
+            <a:ext cx="7909560" cy="310896"/>
+          </a:xfrm>
+          <a:prstGeom prst="rect">
+            <a:avLst/>
+          </a:prstGeom>
+          <a:noFill/>
+        </p:spPr>
+        <p:txBody>
+          <a:bodyPr wrap="square" lIns="36576" tIns="36576" rIns="36576" bIns="36576" anchor="t">
+            <a:spAutoFit/>
+          </a:bodyPr>
+          <a:lstStyle/>
+          <a:p>
+            <a:r>
+              <a:rPr sz="1300" b="0">
+                <a:solidFill>
+                  <a:srgbClr val="F3F7FC"/>
+                </a:solidFill>
+                <a:latin typeface="Aptos"/>
+              </a:rPr>
+              <a:t>over Angular / plain HTML: lighter, fast dev server</a:t>
+            </a:r>
+          </a:p>
+        </p:txBody>
+      </p:sp>
+      <p:sp>
+        <p:nvSpPr>
+          <p:cNvPr id="12" name="Rounded Rectangle 11"/>
+          <p:cNvSpPr/>
+          <p:nvPr/>
+        </p:nvSpPr>
+        <p:spPr>
+          <a:xfrm>
+            <a:off x="658368" y="2706624"/>
+            <a:ext cx="2514600" cy="475488"/>
+          </a:xfrm>
+          <a:prstGeom prst="roundRect">
+            <a:avLst>
+              <a:gd name="adj" fmla="val 12000"/>
+            </a:avLst>
+          </a:prstGeom>
+          <a:solidFill>
+            <a:srgbClr val="1D2B44"/>
+          </a:solidFill>
+          <a:ln>
+            <a:noFill/>
+          </a:ln>
+        </p:spPr>
+        <p:style>
+          <a:lnRef idx="1">
+            <a:schemeClr val="accent1"/>
+          </a:lnRef>
+          <a:fillRef idx="3">
+            <a:schemeClr val="accent1"/>
+          </a:fillRef>
+          <a:effectRef idx="2">
+            <a:schemeClr val="accent1"/>
+          </a:effectRef>
+          <a:fontRef idx="minor">
+            <a:schemeClr val="lt1"/>
+          </a:fontRef>
+        </p:style>
+        <p:txBody>
+          <a:bodyPr rtlCol="0" anchor="ctr"/>
+          <a:lstStyle/>
+          <a:p>
+            <a:pPr algn="ctr"/>
+            <a:endParaRPr/>
+          </a:p>
+        </p:txBody>
+      </p:sp>
+      <p:sp>
+        <p:nvSpPr>
+          <p:cNvPr id="13" name="TextBox 12"/>
+          <p:cNvSpPr txBox="1"/>
+          <p:nvPr/>
+        </p:nvSpPr>
+        <p:spPr>
+          <a:xfrm>
+            <a:off x="804672" y="2788920"/>
+            <a:ext cx="2240280" cy="256032"/>
+          </a:xfrm>
+          <a:prstGeom prst="rect">
+            <a:avLst/>
+          </a:prstGeom>
+          <a:noFill/>
+        </p:spPr>
+        <p:txBody>
+          <a:bodyPr wrap="square" lIns="36576" tIns="36576" rIns="36576" bIns="36576" anchor="t">
+            <a:spAutoFit/>
+          </a:bodyPr>
+          <a:lstStyle/>
+          <a:p>
+            <a:r>
+              <a:rPr sz="1200" b="1">
+                <a:solidFill>
+                  <a:srgbClr val="45D3E6"/>
+                </a:solidFill>
+                <a:latin typeface="Aptos"/>
+              </a:rPr>
+              <a:t>PostgreSQL</a:t>
+            </a:r>
+          </a:p>
+        </p:txBody>
+      </p:sp>
+      <p:sp>
+        <p:nvSpPr>
+          <p:cNvPr id="14" name="TextBox 13"/>
+          <p:cNvSpPr txBox="1"/>
+          <p:nvPr/>
+        </p:nvSpPr>
+        <p:spPr>
+          <a:xfrm>
+            <a:off x="3429000" y="2770632"/>
+            <a:ext cx="7909560" cy="310896"/>
+          </a:xfrm>
+          <a:prstGeom prst="rect">
+            <a:avLst/>
+          </a:prstGeom>
+          <a:noFill/>
+        </p:spPr>
+        <p:txBody>
+          <a:bodyPr wrap="square" lIns="36576" tIns="36576" rIns="36576" bIns="36576" anchor="t">
+            <a:spAutoFit/>
+          </a:bodyPr>
+          <a:lstStyle/>
+          <a:p>
+            <a:r>
+              <a:rPr sz="1300" b="0">
+                <a:solidFill>
+                  <a:srgbClr val="F3F7FC"/>
+                </a:solidFill>
+                <a:latin typeface="Aptos"/>
+              </a:rPr>
+              <a:t>over MySQL / MongoDB: relational data with strict constraints</a:t>
+            </a:r>
+          </a:p>
+        </p:txBody>
+      </p:sp>
+      <p:sp>
+        <p:nvSpPr>
+          <p:cNvPr id="15" name="Rounded Rectangle 14"/>
+          <p:cNvSpPr/>
+          <p:nvPr/>
+        </p:nvSpPr>
+        <p:spPr>
+          <a:xfrm>
+            <a:off x="658368" y="3337560"/>
+            <a:ext cx="2514600" cy="475488"/>
+          </a:xfrm>
+          <a:prstGeom prst="roundRect">
+            <a:avLst>
+              <a:gd name="adj" fmla="val 12000"/>
+            </a:avLst>
+          </a:prstGeom>
+          <a:solidFill>
+            <a:srgbClr val="1D2B44"/>
+          </a:solidFill>
+          <a:ln>
+            <a:noFill/>
+          </a:ln>
+        </p:spPr>
+        <p:style>
+          <a:lnRef idx="1">
+            <a:schemeClr val="accent1"/>
+          </a:lnRef>
+          <a:fillRef idx="3">
+            <a:schemeClr val="accent1"/>
+          </a:fillRef>
+          <a:effectRef idx="2">
+            <a:schemeClr val="accent1"/>
+          </a:effectRef>
+          <a:fontRef idx="minor">
+            <a:schemeClr val="lt1"/>
+          </a:fontRef>
+        </p:style>
+        <p:txBody>
+          <a:bodyPr rtlCol="0" anchor="ctr"/>
+          <a:lstStyle/>
+          <a:p>
+            <a:pPr algn="ctr"/>
+            <a:endParaRPr/>
+          </a:p>
+        </p:txBody>
+      </p:sp>
+      <p:sp>
+        <p:nvSpPr>
+          <p:cNvPr id="16" name="TextBox 15"/>
+          <p:cNvSpPr txBox="1"/>
+          <p:nvPr/>
+        </p:nvSpPr>
+        <p:spPr>
+          <a:xfrm>
+            <a:off x="804672" y="3419856"/>
+            <a:ext cx="2240280" cy="256032"/>
+          </a:xfrm>
+          <a:prstGeom prst="rect">
+            <a:avLst/>
+          </a:prstGeom>
+          <a:noFill/>
+        </p:spPr>
+        <p:txBody>
+          <a:bodyPr wrap="square" lIns="36576" tIns="36576" rIns="36576" bIns="36576" anchor="t">
+            <a:spAutoFit/>
+          </a:bodyPr>
+          <a:lstStyle/>
+          <a:p>
+            <a:r>
+              <a:rPr sz="1200" b="1">
+                <a:solidFill>
+                  <a:srgbClr val="45D3E6"/>
+                </a:solidFill>
+                <a:latin typeface="Aptos"/>
+              </a:rPr>
+              <a:t>GitHub Actions</a:t>
+            </a:r>
+          </a:p>
+        </p:txBody>
+      </p:sp>
+      <p:sp>
+        <p:nvSpPr>
+          <p:cNvPr id="17" name="TextBox 16"/>
+          <p:cNvSpPr txBox="1"/>
+          <p:nvPr/>
+        </p:nvSpPr>
+        <p:spPr>
+          <a:xfrm>
+            <a:off x="3429000" y="3401568"/>
+            <a:ext cx="7909560" cy="310896"/>
+          </a:xfrm>
+          <a:prstGeom prst="rect">
+            <a:avLst/>
+          </a:prstGeom>
+          <a:noFill/>
+        </p:spPr>
+        <p:txBody>
+          <a:bodyPr wrap="square" lIns="36576" tIns="36576" rIns="36576" bIns="36576" anchor="t">
+            <a:spAutoFit/>
+          </a:bodyPr>
+          <a:lstStyle/>
+          <a:p>
+            <a:r>
+              <a:rPr sz="1300" b="0">
+                <a:solidFill>
+                  <a:srgbClr val="F3F7FC"/>
+                </a:solidFill>
+                <a:latin typeface="Aptos"/>
+              </a:rPr>
+              <a:t>over Jenkins: lives next to the code, no CI server to run</a:t>
+            </a:r>
+          </a:p>
+        </p:txBody>
+      </p:sp>
+      <p:sp>
+        <p:nvSpPr>
+          <p:cNvPr id="18" name="Rounded Rectangle 17"/>
+          <p:cNvSpPr/>
+          <p:nvPr/>
+        </p:nvSpPr>
+        <p:spPr>
+          <a:xfrm>
+            <a:off x="658368" y="3968496"/>
+            <a:ext cx="2514600" cy="475488"/>
+          </a:xfrm>
+          <a:prstGeom prst="roundRect">
+            <a:avLst>
+              <a:gd name="adj" fmla="val 12000"/>
+            </a:avLst>
+          </a:prstGeom>
+          <a:solidFill>
+            <a:srgbClr val="1D2B44"/>
+          </a:solidFill>
+          <a:ln>
+            <a:noFill/>
+          </a:ln>
+        </p:spPr>
+        <p:style>
+          <a:lnRef idx="1">
+            <a:schemeClr val="accent1"/>
+          </a:lnRef>
+          <a:fillRef idx="3">
+            <a:schemeClr val="accent1"/>
+          </a:fillRef>
+          <a:effectRef idx="2">
+            <a:schemeClr val="accent1"/>
+          </a:effectRef>
+          <a:fontRef idx="minor">
+            <a:schemeClr val="lt1"/>
+          </a:fontRef>
+        </p:style>
+        <p:txBody>
+          <a:bodyPr rtlCol="0" anchor="ctr"/>
+          <a:lstStyle/>
+          <a:p>
+            <a:pPr algn="ctr"/>
+            <a:endParaRPr/>
+          </a:p>
+        </p:txBody>
+      </p:sp>
+      <p:sp>
+        <p:nvSpPr>
+          <p:cNvPr id="19" name="TextBox 18"/>
+          <p:cNvSpPr txBox="1"/>
+          <p:nvPr/>
+        </p:nvSpPr>
+        <p:spPr>
+          <a:xfrm>
+            <a:off x="804672" y="4050791"/>
+            <a:ext cx="2240280" cy="256032"/>
+          </a:xfrm>
+          <a:prstGeom prst="rect">
+            <a:avLst/>
+          </a:prstGeom>
+          <a:noFill/>
+        </p:spPr>
+        <p:txBody>
+          <a:bodyPr wrap="square" lIns="36576" tIns="36576" rIns="36576" bIns="36576" anchor="t">
+            <a:spAutoFit/>
+          </a:bodyPr>
+          <a:lstStyle/>
+          <a:p>
+            <a:r>
+              <a:rPr sz="1200" b="1">
+                <a:solidFill>
+                  <a:srgbClr val="45D3E6"/>
+                </a:solidFill>
+                <a:latin typeface="Aptos"/>
+              </a:rPr>
+              <a:t>Kubernetes + Helm</a:t>
+            </a:r>
+          </a:p>
+        </p:txBody>
+      </p:sp>
+      <p:sp>
+        <p:nvSpPr>
+          <p:cNvPr id="20" name="TextBox 19"/>
+          <p:cNvSpPr txBox="1"/>
+          <p:nvPr/>
+        </p:nvSpPr>
+        <p:spPr>
+          <a:xfrm>
+            <a:off x="3429000" y="4032504"/>
+            <a:ext cx="7909560" cy="310896"/>
+          </a:xfrm>
+          <a:prstGeom prst="rect">
+            <a:avLst/>
+          </a:prstGeom>
+          <a:noFill/>
+        </p:spPr>
+        <p:txBody>
+          <a:bodyPr wrap="square" lIns="36576" tIns="36576" rIns="36576" bIns="36576" anchor="t">
+            <a:spAutoFit/>
+          </a:bodyPr>
+          <a:lstStyle/>
+          <a:p>
+            <a:r>
+              <a:rPr sz="1300" b="0">
+                <a:solidFill>
+                  <a:srgbClr val="F3F7FC"/>
+                </a:solidFill>
+                <a:latin typeface="Aptos"/>
+              </a:rPr>
+              <a:t>over Docker Swarm: industry standard, one chart for every env</a:t>
+            </a:r>
+          </a:p>
+        </p:txBody>
+      </p:sp>
+      <p:sp>
+        <p:nvSpPr>
+          <p:cNvPr id="21" name="Rounded Rectangle 20"/>
+          <p:cNvSpPr/>
+          <p:nvPr/>
+        </p:nvSpPr>
+        <p:spPr>
+          <a:xfrm>
+            <a:off x="658368" y="4599431"/>
+            <a:ext cx="2514600" cy="475488"/>
+          </a:xfrm>
+          <a:prstGeom prst="roundRect">
+            <a:avLst>
+              <a:gd name="adj" fmla="val 12000"/>
+            </a:avLst>
+          </a:prstGeom>
+          <a:solidFill>
+            <a:srgbClr val="1D2B44"/>
+          </a:solidFill>
+          <a:ln>
+            <a:noFill/>
+          </a:ln>
+        </p:spPr>
+        <p:style>
+          <a:lnRef idx="1">
+            <a:schemeClr val="accent1"/>
+          </a:lnRef>
+          <a:fillRef idx="3">
+            <a:schemeClr val="accent1"/>
+          </a:fillRef>
+          <a:effectRef idx="2">
+            <a:schemeClr val="accent1"/>
+          </a:effectRef>
+          <a:fontRef idx="minor">
+            <a:schemeClr val="lt1"/>
+          </a:fontRef>
+        </p:style>
+        <p:txBody>
+          <a:bodyPr rtlCol="0" anchor="ctr"/>
+          <a:lstStyle/>
+          <a:p>
+            <a:pPr algn="ctr"/>
+            <a:endParaRPr/>
+          </a:p>
+        </p:txBody>
+      </p:sp>
+      <p:sp>
+        <p:nvSpPr>
+          <p:cNvPr id="22" name="TextBox 21"/>
+          <p:cNvSpPr txBox="1"/>
+          <p:nvPr/>
+        </p:nvSpPr>
+        <p:spPr>
+          <a:xfrm>
+            <a:off x="804672" y="4681727"/>
+            <a:ext cx="2240280" cy="256032"/>
+          </a:xfrm>
+          <a:prstGeom prst="rect">
+            <a:avLst/>
+          </a:prstGeom>
+          <a:noFill/>
+        </p:spPr>
+        <p:txBody>
+          <a:bodyPr wrap="square" lIns="36576" tIns="36576" rIns="36576" bIns="36576" anchor="t">
+            <a:spAutoFit/>
+          </a:bodyPr>
+          <a:lstStyle/>
+          <a:p>
+            <a:r>
+              <a:rPr sz="1200" b="1">
+                <a:solidFill>
+                  <a:srgbClr val="45D3E6"/>
+                </a:solidFill>
+                <a:latin typeface="Aptos"/>
+              </a:rPr>
+              <a:t>Argo CD</a:t>
+            </a:r>
+          </a:p>
+        </p:txBody>
+      </p:sp>
+      <p:sp>
+        <p:nvSpPr>
+          <p:cNvPr id="23" name="TextBox 22"/>
+          <p:cNvSpPr txBox="1"/>
+          <p:nvPr/>
+        </p:nvSpPr>
+        <p:spPr>
+          <a:xfrm>
+            <a:off x="3429000" y="4663440"/>
+            <a:ext cx="7909560" cy="310896"/>
+          </a:xfrm>
+          <a:prstGeom prst="rect">
+            <a:avLst/>
+          </a:prstGeom>
+          <a:noFill/>
+        </p:spPr>
+        <p:txBody>
+          <a:bodyPr wrap="square" lIns="36576" tIns="36576" rIns="36576" bIns="36576" anchor="t">
+            <a:spAutoFit/>
+          </a:bodyPr>
+          <a:lstStyle/>
+          <a:p>
+            <a:r>
+              <a:rPr sz="1300" b="0">
+                <a:solidFill>
+                  <a:srgbClr val="F3F7FC"/>
+                </a:solidFill>
+                <a:latin typeface="Aptos"/>
+              </a:rPr>
+              <a:t>over Flux / push deploys: UI shows sync state and drift</a:t>
+            </a:r>
+          </a:p>
+        </p:txBody>
+      </p:sp>
+      <p:sp>
+        <p:nvSpPr>
+          <p:cNvPr id="24" name="Rounded Rectangle 23"/>
+          <p:cNvSpPr/>
+          <p:nvPr/>
+        </p:nvSpPr>
+        <p:spPr>
+          <a:xfrm>
+            <a:off x="658368" y="5230368"/>
+            <a:ext cx="2514600" cy="475488"/>
+          </a:xfrm>
+          <a:prstGeom prst="roundRect">
+            <a:avLst>
+              <a:gd name="adj" fmla="val 12000"/>
+            </a:avLst>
+          </a:prstGeom>
+          <a:solidFill>
+            <a:srgbClr val="1D2B44"/>
+          </a:solidFill>
+          <a:ln>
+            <a:noFill/>
+          </a:ln>
+        </p:spPr>
+        <p:style>
+          <a:lnRef idx="1">
+            <a:schemeClr val="accent1"/>
+          </a:lnRef>
+          <a:fillRef idx="3">
+            <a:schemeClr val="accent1"/>
+          </a:fillRef>
+          <a:effectRef idx="2">
+            <a:schemeClr val="accent1"/>
+          </a:effectRef>
+          <a:fontRef idx="minor">
+            <a:schemeClr val="lt1"/>
+          </a:fontRef>
+        </p:style>
+        <p:txBody>
+          <a:bodyPr rtlCol="0" anchor="ctr"/>
+          <a:lstStyle/>
+          <a:p>
+            <a:pPr algn="ctr"/>
+            <a:endParaRPr/>
+          </a:p>
+        </p:txBody>
+      </p:sp>
+      <p:sp>
+        <p:nvSpPr>
+          <p:cNvPr id="25" name="TextBox 24"/>
+          <p:cNvSpPr txBox="1"/>
+          <p:nvPr/>
+        </p:nvSpPr>
+        <p:spPr>
+          <a:xfrm>
+            <a:off x="804672" y="5312664"/>
+            <a:ext cx="2240280" cy="256032"/>
+          </a:xfrm>
+          <a:prstGeom prst="rect">
+            <a:avLst/>
+          </a:prstGeom>
+          <a:noFill/>
+        </p:spPr>
+        <p:txBody>
+          <a:bodyPr wrap="square" lIns="36576" tIns="36576" rIns="36576" bIns="36576" anchor="t">
+            <a:spAutoFit/>
+          </a:bodyPr>
+          <a:lstStyle/>
+          <a:p>
+            <a:r>
+              <a:rPr sz="1200" b="1">
+                <a:solidFill>
+                  <a:srgbClr val="45D3E6"/>
+                </a:solidFill>
+                <a:latin typeface="Aptos"/>
+              </a:rPr>
+              <a:t>Terraform</a:t>
+            </a:r>
+          </a:p>
+        </p:txBody>
+      </p:sp>
+      <p:sp>
+        <p:nvSpPr>
+          <p:cNvPr id="26" name="TextBox 25"/>
+          <p:cNvSpPr txBox="1"/>
+          <p:nvPr/>
+        </p:nvSpPr>
+        <p:spPr>
+          <a:xfrm>
+            <a:off x="3429000" y="5294376"/>
+            <a:ext cx="7909560" cy="310896"/>
+          </a:xfrm>
+          <a:prstGeom prst="rect">
+            <a:avLst/>
+          </a:prstGeom>
+          <a:noFill/>
+        </p:spPr>
+        <p:txBody>
+          <a:bodyPr wrap="square" lIns="36576" tIns="36576" rIns="36576" bIns="36576" anchor="t">
+            <a:spAutoFit/>
+          </a:bodyPr>
+          <a:lstStyle/>
+          <a:p>
+            <a:r>
+              <a:rPr sz="1300" b="0">
+                <a:solidFill>
+                  <a:srgbClr val="F3F7FC"/>
+                </a:solidFill>
+                <a:latin typeface="Aptos"/>
+              </a:rPr>
+              <a:t>over CloudFormation: cloud-agnostic, reusable VPC/EKS modules</a:t>
+            </a:r>
+          </a:p>
+        </p:txBody>
+      </p:sp>
+    </p:spTree>
+  </p:cSld>
+  <p:clrMapOvr>
+    <a:masterClrMapping/>
+  </p:clrMapOvr>
+</p:sld>
+</file>
+
 <file path=ppt/slides/slide2.xml><?xml version="1.0" encoding="utf-8"?>
 <p:sld xmlns:a="http://schemas.openxmlformats.org/drawingml/2006/main" xmlns:r="http://schemas.openxmlformats.org/officeDocument/2006/relationships" xmlns:p="http://schemas.openxmlformats.org/presentationml/2006/main">
   <p:cSld>
@@ -12354,7 +13326,7 @@
                 </a:solidFill>
                 <a:latin typeface="Aptos"/>
               </a:rPr>
-              <a:t>06</a:t>
+              <a:t>07</a:t>
             </a:r>
           </a:p>
         </p:txBody>
@@ -12784,7 +13756,7 @@
                 </a:solidFill>
                 <a:latin typeface="Aptos"/>
               </a:rPr>
-              <a:t>07</a:t>
+              <a:t>08</a:t>
             </a:r>
           </a:p>
         </p:txBody>
@@ -13286,7 +14258,7 @@
                 </a:solidFill>
                 <a:latin typeface="Aptos"/>
               </a:rPr>
-              <a:t>08</a:t>
+              <a:t>09</a:t>
             </a:r>
           </a:p>
         </p:txBody>

</xml_diff>